<commit_message>
Update final PDF submission link
</commit_message>
<xml_diff>
--- a/docs/code_explanation_presentation.pptx
+++ b/docs/code_explanation_presentation.pptx
@@ -3206,7 +3206,7 @@
                 </a:solidFill>
                 <a:latin typeface="Arial"/>
               </a:rPr>
-              <a:t>Presenter: ISSA ISSA RASHID | Repository: https://github.com/IssaIssa-tech/AI-final-report</a:t>
+              <a:t>Presenter: ISSA ISSA RASHID</a:t>
             </a:r>
           </a:p>
         </p:txBody>
@@ -3286,7 +3286,7 @@
                 </a:solidFill>
                 <a:latin typeface="Arial"/>
               </a:rPr>
-              <a:t>AI-final-report code explanation | https://github.com/IssaIssa-tech/AI-final-report</a:t>
+              <a:t>AI-final-report code explanation</a:t>
             </a:r>
           </a:p>
         </p:txBody>
@@ -4016,7 +4016,7 @@
                 </a:solidFill>
                 <a:latin typeface="Arial"/>
               </a:rPr>
-              <a:t>AI-final-report code explanation | https://github.com/IssaIssa-tech/AI-final-report</a:t>
+              <a:t>AI-final-report code explanation</a:t>
             </a:r>
           </a:p>
         </p:txBody>
@@ -4285,7 +4285,7 @@
                 </a:solidFill>
                 <a:latin typeface="Arial"/>
               </a:rPr>
-              <a:t>AI-final-report code explanation | https://github.com/IssaIssa-tech/AI-final-report</a:t>
+              <a:t>AI-final-report code explanation</a:t>
             </a:r>
           </a:p>
         </p:txBody>
@@ -4470,11 +4470,11 @@
                 </a:solidFill>
                 <a:latin typeface="Arial"/>
               </a:rPr>
-              <a:t>Q: What is the GitHub link?</a:t>
+              <a:t>Q: Where is the source-code link?</a:t>
             </a:r>
             <a:br/>
             <a:r>
-              <a:t>A: https://github.com/IssaIssa-tech/AI-final-report</a:t>
+              <a:t>A: It is included in the final paper's Code Availability section.</a:t>
             </a:r>
           </a:p>
         </p:txBody>
@@ -4554,7 +4554,7 @@
                 </a:solidFill>
                 <a:latin typeface="Arial"/>
               </a:rPr>
-              <a:t>AI-final-report code explanation | https://github.com/IssaIssa-tech/AI-final-report</a:t>
+              <a:t>AI-final-report code explanation</a:t>
             </a:r>
           </a:p>
         </p:txBody>
@@ -4865,7 +4865,7 @@
                 </a:solidFill>
                 <a:latin typeface="Arial"/>
               </a:rPr>
-              <a:t>AI-final-report code explanation | https://github.com/IssaIssa-tech/AI-final-report</a:t>
+              <a:t>AI-final-report code explanation</a:t>
             </a:r>
           </a:p>
         </p:txBody>
@@ -5102,7 +5102,7 @@
                 </a:solidFill>
                 <a:latin typeface="Arial"/>
               </a:rPr>
-              <a:t>AI-final-report code explanation | https://github.com/IssaIssa-tech/AI-final-report</a:t>
+              <a:t>AI-final-report code explanation</a:t>
             </a:r>
           </a:p>
         </p:txBody>
@@ -5455,7 +5455,7 @@
                 </a:solidFill>
                 <a:latin typeface="Arial"/>
               </a:rPr>
-              <a:t>AI-final-report code explanation | https://github.com/IssaIssa-tech/AI-final-report</a:t>
+              <a:t>AI-final-report code explanation</a:t>
             </a:r>
           </a:p>
         </p:txBody>
@@ -6100,7 +6100,7 @@
                 </a:solidFill>
                 <a:latin typeface="Arial"/>
               </a:rPr>
-              <a:t>AI-final-report code explanation | https://github.com/IssaIssa-tech/AI-final-report</a:t>
+              <a:t>AI-final-report code explanation</a:t>
             </a:r>
           </a:p>
         </p:txBody>
@@ -6464,7 +6464,7 @@
                 </a:solidFill>
                 <a:latin typeface="Arial"/>
               </a:rPr>
-              <a:t>AI-final-report code explanation | https://github.com/IssaIssa-tech/AI-final-report</a:t>
+              <a:t>AI-final-report code explanation</a:t>
             </a:r>
           </a:p>
         </p:txBody>
@@ -6801,7 +6801,7 @@
                 </a:solidFill>
                 <a:latin typeface="Arial"/>
               </a:rPr>
-              <a:t>AI-final-report code explanation | https://github.com/IssaIssa-tech/AI-final-report</a:t>
+              <a:t>AI-final-report code explanation</a:t>
             </a:r>
           </a:p>
         </p:txBody>
@@ -7155,7 +7155,7 @@
                 </a:solidFill>
                 <a:latin typeface="Arial"/>
               </a:rPr>
-              <a:t>AI-final-report code explanation | https://github.com/IssaIssa-tech/AI-final-report</a:t>
+              <a:t>AI-final-report code explanation</a:t>
             </a:r>
           </a:p>
         </p:txBody>
@@ -7529,7 +7529,7 @@
                 </a:solidFill>
                 <a:latin typeface="Arial"/>
               </a:rPr>
-              <a:t>AI-final-report code explanation | https://github.com/IssaIssa-tech/AI-final-report</a:t>
+              <a:t>AI-final-report code explanation</a:t>
             </a:r>
           </a:p>
         </p:txBody>
@@ -7846,7 +7846,7 @@
                 </a:solidFill>
                 <a:latin typeface="Arial"/>
               </a:rPr>
-              <a:t>AI-final-report code explanation | https://github.com/IssaIssa-tech/AI-final-report</a:t>
+              <a:t>AI-final-report code explanation</a:t>
             </a:r>
           </a:p>
         </p:txBody>
@@ -8099,7 +8099,7 @@
                 </a:solidFill>
                 <a:latin typeface="Arial"/>
               </a:rPr>
-              <a:t>AI-final-report code explanation | https://github.com/IssaIssa-tech/AI-final-report</a:t>
+              <a:t>AI-final-report code explanation</a:t>
             </a:r>
           </a:p>
         </p:txBody>

</xml_diff>